<commit_message>
Restyle HiSim vs AIConfigurator PPTX to white/red/gray/black
Use white background with red, gray, and black as primary colors for the one-pager slide.

Co-authored-by: Annie <Annie-Summer@users.noreply.github.com>
</commit_message>
<xml_diff>
--- a/docs/competitive/HiSim_vs_AIConfigurator.pptx
+++ b/docs/competitive/HiSim_vs_AIConfigurator.pptx
@@ -3097,13 +3097,13 @@
         <p:spPr>
           <a:xfrm>
             <a:off x="0" y="0"/>
-            <a:ext cx="12191695" cy="658368"/>
+            <a:ext cx="12191695" cy="6858000"/>
           </a:xfrm>
           <a:prstGeom prst="rect">
             <a:avLst/>
           </a:prstGeom>
           <a:solidFill>
-            <a:srgbClr val="1B2A4A"/>
+            <a:srgbClr val="FFFFFF"/>
           </a:solidFill>
           <a:ln>
             <a:noFill/>
@@ -3133,14 +3133,57 @@
       </p:sp>
       <p:sp>
         <p:nvSpPr>
-          <p:cNvPr id="3" name="TextBox 2"/>
+          <p:cNvPr id="3" name="Rectangle 2"/>
+          <p:cNvSpPr/>
+          <p:nvPr/>
+        </p:nvSpPr>
+        <p:spPr>
+          <a:xfrm>
+            <a:off x="0" y="0"/>
+            <a:ext cx="12191695" cy="73152"/>
+          </a:xfrm>
+          <a:prstGeom prst="rect">
+            <a:avLst/>
+          </a:prstGeom>
+          <a:solidFill>
+            <a:srgbClr val="C4281C"/>
+          </a:solidFill>
+          <a:ln>
+            <a:noFill/>
+          </a:ln>
+        </p:spPr>
+        <p:style>
+          <a:lnRef idx="1">
+            <a:schemeClr val="accent1"/>
+          </a:lnRef>
+          <a:fillRef idx="3">
+            <a:schemeClr val="accent1"/>
+          </a:fillRef>
+          <a:effectRef idx="2">
+            <a:schemeClr val="accent1"/>
+          </a:effectRef>
+          <a:fontRef idx="minor">
+            <a:schemeClr val="lt1"/>
+          </a:fontRef>
+        </p:style>
+        <p:txBody>
+          <a:bodyPr rtlCol="0" anchor="ctr"/>
+          <a:lstStyle/>
+          <a:p>
+            <a:pPr algn="ctr"/>
+          </a:p>
+        </p:txBody>
+      </p:sp>
+      <p:sp>
+        <p:nvSpPr>
+          <p:cNvPr id="4" name="TextBox 3"/>
           <p:cNvSpPr txBox="1"/>
           <p:nvPr/>
         </p:nvSpPr>
         <p:spPr>
           <a:xfrm>
-            <a:off x="274320" y="109728"/>
-            <a:ext cx="9144000" cy="457200"/>
+            <a:off x="320040" y="201168"/>
+            <a:ext cx="9326880" cy="384048"/>
           </a:xfrm>
           <a:prstGeom prst="rect">
             <a:avLst/>
@@ -3164,7 +3207,7 @@
             <a:r>
               <a:rPr sz="2000" b="1">
                 <a:solidFill>
-                  <a:srgbClr val="FFFFFF"/>
+                  <a:srgbClr val="1A1A1A"/>
                 </a:solidFill>
                 <a:latin typeface="Microsoft YaHei"/>
                 <a:ea typeface="Microsoft YaHei"/>
@@ -3177,14 +3220,14 @@
       </p:sp>
       <p:sp>
         <p:nvSpPr>
-          <p:cNvPr id="4" name="TextBox 3"/>
+          <p:cNvPr id="5" name="TextBox 4"/>
           <p:cNvSpPr txBox="1"/>
           <p:nvPr/>
         </p:nvSpPr>
         <p:spPr>
           <a:xfrm>
-            <a:off x="8229600" y="201168"/>
-            <a:ext cx="3749039" cy="365760"/>
+            <a:off x="8412480" y="274320"/>
+            <a:ext cx="3474720" cy="292608"/>
           </a:xfrm>
           <a:prstGeom prst="rect">
             <a:avLst/>
@@ -3208,7 +3251,7 @@
             <a:r>
               <a:rPr sz="1100" b="0">
                 <a:solidFill>
-                  <a:srgbClr val="C5D0E0"/>
+                  <a:srgbClr val="6B6B6B"/>
                 </a:solidFill>
                 <a:latin typeface="Microsoft YaHei"/>
                 <a:ea typeface="Microsoft YaHei"/>
@@ -3221,20 +3264,20 @@
       </p:sp>
       <p:sp>
         <p:nvSpPr>
-          <p:cNvPr id="5" name="Rectangle 4"/>
+          <p:cNvPr id="6" name="Rectangle 5"/>
           <p:cNvSpPr/>
           <p:nvPr/>
         </p:nvSpPr>
         <p:spPr>
           <a:xfrm>
-            <a:off x="2148840" y="777240"/>
-            <a:ext cx="4846320" cy="347472"/>
+            <a:off x="320040" y="640080"/>
+            <a:ext cx="11567160" cy="22860"/>
           </a:xfrm>
           <a:prstGeom prst="rect">
             <a:avLst/>
           </a:prstGeom>
           <a:solidFill>
-            <a:srgbClr val="C2410C"/>
+            <a:srgbClr val="D0D0D0"/>
           </a:solidFill>
           <a:ln>
             <a:noFill/>
@@ -3264,20 +3307,20 @@
       </p:sp>
       <p:sp>
         <p:nvSpPr>
-          <p:cNvPr id="6" name="Rectangle 5"/>
+          <p:cNvPr id="7" name="Rectangle 6"/>
           <p:cNvSpPr/>
           <p:nvPr/>
         </p:nvSpPr>
         <p:spPr>
           <a:xfrm>
-            <a:off x="7086600" y="777240"/>
-            <a:ext cx="4846320" cy="347472"/>
+            <a:off x="2148840" y="804672"/>
+            <a:ext cx="4846320" cy="329184"/>
           </a:xfrm>
           <a:prstGeom prst="rect">
             <a:avLst/>
           </a:prstGeom>
           <a:solidFill>
-            <a:srgbClr val="174EA6"/>
+            <a:srgbClr val="C4281C"/>
           </a:solidFill>
           <a:ln>
             <a:noFill/>
@@ -3307,14 +3350,57 @@
       </p:sp>
       <p:sp>
         <p:nvSpPr>
-          <p:cNvPr id="7" name="TextBox 6"/>
+          <p:cNvPr id="8" name="Rectangle 7"/>
+          <p:cNvSpPr/>
+          <p:nvPr/>
+        </p:nvSpPr>
+        <p:spPr>
+          <a:xfrm>
+            <a:off x="7086600" y="804672"/>
+            <a:ext cx="4846320" cy="329184"/>
+          </a:xfrm>
+          <a:prstGeom prst="rect">
+            <a:avLst/>
+          </a:prstGeom>
+          <a:solidFill>
+            <a:srgbClr val="5A5A5A"/>
+          </a:solidFill>
+          <a:ln>
+            <a:noFill/>
+          </a:ln>
+        </p:spPr>
+        <p:style>
+          <a:lnRef idx="1">
+            <a:schemeClr val="accent1"/>
+          </a:lnRef>
+          <a:fillRef idx="3">
+            <a:schemeClr val="accent1"/>
+          </a:fillRef>
+          <a:effectRef idx="2">
+            <a:schemeClr val="accent1"/>
+          </a:effectRef>
+          <a:fontRef idx="minor">
+            <a:schemeClr val="lt1"/>
+          </a:fontRef>
+        </p:style>
+        <p:txBody>
+          <a:bodyPr rtlCol="0" anchor="ctr"/>
+          <a:lstStyle/>
+          <a:p>
+            <a:pPr algn="ctr"/>
+          </a:p>
+        </p:txBody>
+      </p:sp>
+      <p:sp>
+        <p:nvSpPr>
+          <p:cNvPr id="9" name="TextBox 8"/>
           <p:cNvSpPr txBox="1"/>
           <p:nvPr/>
         </p:nvSpPr>
         <p:spPr>
           <a:xfrm>
-            <a:off x="182880" y="804672"/>
-            <a:ext cx="1828800" cy="320040"/>
+            <a:off x="228600" y="841248"/>
+            <a:ext cx="1828800" cy="292608"/>
           </a:xfrm>
           <a:prstGeom prst="rect">
             <a:avLst/>
@@ -3338,7 +3424,7 @@
             <a:r>
               <a:rPr sz="1200" b="1">
                 <a:solidFill>
-                  <a:srgbClr val="1B2A4A"/>
+                  <a:srgbClr val="1A1A1A"/>
                 </a:solidFill>
                 <a:latin typeface="Microsoft YaHei"/>
                 <a:ea typeface="Microsoft YaHei"/>
@@ -3351,14 +3437,14 @@
       </p:sp>
       <p:sp>
         <p:nvSpPr>
-          <p:cNvPr id="8" name="TextBox 7"/>
+          <p:cNvPr id="10" name="TextBox 9"/>
           <p:cNvSpPr txBox="1"/>
           <p:nvPr/>
         </p:nvSpPr>
         <p:spPr>
           <a:xfrm>
-            <a:off x="2148840" y="804672"/>
-            <a:ext cx="4846320" cy="320040"/>
+            <a:off x="2148840" y="841248"/>
+            <a:ext cx="4846320" cy="292608"/>
           </a:xfrm>
           <a:prstGeom prst="rect">
             <a:avLst/>
@@ -3395,14 +3481,14 @@
       </p:sp>
       <p:sp>
         <p:nvSpPr>
-          <p:cNvPr id="9" name="TextBox 8"/>
+          <p:cNvPr id="11" name="TextBox 10"/>
           <p:cNvSpPr txBox="1"/>
           <p:nvPr/>
         </p:nvSpPr>
         <p:spPr>
           <a:xfrm>
-            <a:off x="7086600" y="804672"/>
-            <a:ext cx="4846320" cy="320040"/>
+            <a:off x="7086600" y="841248"/>
+            <a:ext cx="4846320" cy="292608"/>
           </a:xfrm>
           <a:prstGeom prst="rect">
             <a:avLst/>
@@ -3439,20 +3525,20 @@
       </p:sp>
       <p:sp>
         <p:nvSpPr>
-          <p:cNvPr id="10" name="Rectangle 9"/>
+          <p:cNvPr id="12" name="Rectangle 11"/>
           <p:cNvSpPr/>
           <p:nvPr/>
         </p:nvSpPr>
         <p:spPr>
           <a:xfrm>
-            <a:off x="182880" y="1170432"/>
-            <a:ext cx="11841480" cy="777240"/>
+            <a:off x="228600" y="1188720"/>
+            <a:ext cx="11750040" cy="749808"/>
           </a:xfrm>
           <a:prstGeom prst="rect">
             <a:avLst/>
           </a:prstGeom>
           <a:solidFill>
-            <a:srgbClr val="F5F7FA"/>
+            <a:srgbClr val="F5F5F5"/>
           </a:solidFill>
           <a:ln>
             <a:noFill/>
@@ -3482,20 +3568,20 @@
       </p:sp>
       <p:sp>
         <p:nvSpPr>
-          <p:cNvPr id="11" name="Rectangle 10"/>
+          <p:cNvPr id="13" name="Rectangle 12"/>
           <p:cNvSpPr/>
           <p:nvPr/>
         </p:nvSpPr>
         <p:spPr>
           <a:xfrm>
-            <a:off x="182880" y="1170432"/>
-            <a:ext cx="73152" cy="777240"/>
+            <a:off x="228600" y="1188720"/>
+            <a:ext cx="64008" cy="749808"/>
           </a:xfrm>
           <a:prstGeom prst="rect">
             <a:avLst/>
           </a:prstGeom>
           <a:solidFill>
-            <a:srgbClr val="1B2A4A"/>
+            <a:srgbClr val="C4281C"/>
           </a:solidFill>
           <a:ln>
             <a:noFill/>
@@ -3525,14 +3611,57 @@
       </p:sp>
       <p:sp>
         <p:nvSpPr>
-          <p:cNvPr id="12" name="TextBox 11"/>
+          <p:cNvPr id="14" name="Rectangle 13"/>
+          <p:cNvSpPr/>
+          <p:nvPr/>
+        </p:nvSpPr>
+        <p:spPr>
+          <a:xfrm>
+            <a:off x="228600" y="1927555"/>
+            <a:ext cx="11750040" cy="10972"/>
+          </a:xfrm>
+          <a:prstGeom prst="rect">
+            <a:avLst/>
+          </a:prstGeom>
+          <a:solidFill>
+            <a:srgbClr val="D0D0D0"/>
+          </a:solidFill>
+          <a:ln>
+            <a:noFill/>
+          </a:ln>
+        </p:spPr>
+        <p:style>
+          <a:lnRef idx="1">
+            <a:schemeClr val="accent1"/>
+          </a:lnRef>
+          <a:fillRef idx="3">
+            <a:schemeClr val="accent1"/>
+          </a:fillRef>
+          <a:effectRef idx="2">
+            <a:schemeClr val="accent1"/>
+          </a:effectRef>
+          <a:fontRef idx="minor">
+            <a:schemeClr val="lt1"/>
+          </a:fontRef>
+        </p:style>
+        <p:txBody>
+          <a:bodyPr rtlCol="0" anchor="ctr"/>
+          <a:lstStyle/>
+          <a:p>
+            <a:pPr algn="ctr"/>
+          </a:p>
+        </p:txBody>
+      </p:sp>
+      <p:sp>
+        <p:nvSpPr>
+          <p:cNvPr id="15" name="TextBox 14"/>
           <p:cNvSpPr txBox="1"/>
           <p:nvPr/>
         </p:nvSpPr>
         <p:spPr>
           <a:xfrm>
-            <a:off x="320040" y="1243584"/>
-            <a:ext cx="1737360" cy="685800"/>
+            <a:off x="365760" y="1261872"/>
+            <a:ext cx="1691640" cy="640080"/>
           </a:xfrm>
           <a:prstGeom prst="rect">
             <a:avLst/>
@@ -3556,7 +3685,7 @@
             <a:r>
               <a:rPr sz="1100" b="1">
                 <a:solidFill>
-                  <a:srgbClr val="1B2A4A"/>
+                  <a:srgbClr val="1A1A1A"/>
                 </a:solidFill>
                 <a:latin typeface="Microsoft YaHei"/>
                 <a:ea typeface="Microsoft YaHei"/>
@@ -3569,14 +3698,14 @@
       </p:sp>
       <p:sp>
         <p:nvSpPr>
-          <p:cNvPr id="13" name="TextBox 12"/>
+          <p:cNvPr id="16" name="TextBox 15"/>
           <p:cNvSpPr txBox="1"/>
           <p:nvPr/>
         </p:nvSpPr>
         <p:spPr>
           <a:xfrm>
-            <a:off x="2194560" y="1225296"/>
-            <a:ext cx="4709160" cy="704088"/>
+            <a:off x="2194560" y="1243584"/>
+            <a:ext cx="4709160" cy="676656"/>
           </a:xfrm>
           <a:prstGeom prst="rect">
             <a:avLst/>
@@ -3600,7 +3729,7 @@
             <a:r>
               <a:rPr sz="950" b="0">
                 <a:solidFill>
-                  <a:srgbClr val="1F2937"/>
+                  <a:srgbClr val="4A4A4A"/>
                 </a:solidFill>
                 <a:latin typeface="Microsoft YaHei"/>
                 <a:ea typeface="Microsoft YaHei"/>
@@ -3613,14 +3742,14 @@
       </p:sp>
       <p:sp>
         <p:nvSpPr>
-          <p:cNvPr id="14" name="TextBox 13"/>
+          <p:cNvPr id="17" name="TextBox 16"/>
           <p:cNvSpPr txBox="1"/>
           <p:nvPr/>
         </p:nvSpPr>
         <p:spPr>
           <a:xfrm>
-            <a:off x="7132320" y="1225296"/>
-            <a:ext cx="4709160" cy="704088"/>
+            <a:off x="7132320" y="1243584"/>
+            <a:ext cx="4709160" cy="676656"/>
           </a:xfrm>
           <a:prstGeom prst="rect">
             <a:avLst/>
@@ -3644,7 +3773,7 @@
             <a:r>
               <a:rPr sz="950" b="0">
                 <a:solidFill>
-                  <a:srgbClr val="1F2937"/>
+                  <a:srgbClr val="4A4A4A"/>
                 </a:solidFill>
                 <a:latin typeface="Microsoft YaHei"/>
                 <a:ea typeface="Microsoft YaHei"/>
@@ -3657,14 +3786,14 @@
       </p:sp>
       <p:sp>
         <p:nvSpPr>
-          <p:cNvPr id="15" name="Rectangle 14"/>
+          <p:cNvPr id="18" name="Rectangle 17"/>
           <p:cNvSpPr/>
           <p:nvPr/>
         </p:nvSpPr>
         <p:spPr>
           <a:xfrm>
-            <a:off x="182880" y="1947672"/>
-            <a:ext cx="11841480" cy="1051560"/>
+            <a:off x="228600" y="1938528"/>
+            <a:ext cx="11750040" cy="1024128"/>
           </a:xfrm>
           <a:prstGeom prst="rect">
             <a:avLst/>
@@ -3700,20 +3829,20 @@
       </p:sp>
       <p:sp>
         <p:nvSpPr>
-          <p:cNvPr id="16" name="Rectangle 15"/>
+          <p:cNvPr id="19" name="Rectangle 18"/>
           <p:cNvSpPr/>
           <p:nvPr/>
         </p:nvSpPr>
         <p:spPr>
           <a:xfrm>
-            <a:off x="182880" y="1947672"/>
-            <a:ext cx="73152" cy="1051560"/>
+            <a:off x="228600" y="1938528"/>
+            <a:ext cx="64008" cy="1024128"/>
           </a:xfrm>
           <a:prstGeom prst="rect">
             <a:avLst/>
           </a:prstGeom>
           <a:solidFill>
-            <a:srgbClr val="1B2A4A"/>
+            <a:srgbClr val="C4281C"/>
           </a:solidFill>
           <a:ln>
             <a:noFill/>
@@ -3743,14 +3872,57 @@
       </p:sp>
       <p:sp>
         <p:nvSpPr>
-          <p:cNvPr id="17" name="TextBox 16"/>
+          <p:cNvPr id="20" name="Rectangle 19"/>
+          <p:cNvSpPr/>
+          <p:nvPr/>
+        </p:nvSpPr>
+        <p:spPr>
+          <a:xfrm>
+            <a:off x="228600" y="2951683"/>
+            <a:ext cx="11750040" cy="10972"/>
+          </a:xfrm>
+          <a:prstGeom prst="rect">
+            <a:avLst/>
+          </a:prstGeom>
+          <a:solidFill>
+            <a:srgbClr val="D0D0D0"/>
+          </a:solidFill>
+          <a:ln>
+            <a:noFill/>
+          </a:ln>
+        </p:spPr>
+        <p:style>
+          <a:lnRef idx="1">
+            <a:schemeClr val="accent1"/>
+          </a:lnRef>
+          <a:fillRef idx="3">
+            <a:schemeClr val="accent1"/>
+          </a:fillRef>
+          <a:effectRef idx="2">
+            <a:schemeClr val="accent1"/>
+          </a:effectRef>
+          <a:fontRef idx="minor">
+            <a:schemeClr val="lt1"/>
+          </a:fontRef>
+        </p:style>
+        <p:txBody>
+          <a:bodyPr rtlCol="0" anchor="ctr"/>
+          <a:lstStyle/>
+          <a:p>
+            <a:pPr algn="ctr"/>
+          </a:p>
+        </p:txBody>
+      </p:sp>
+      <p:sp>
+        <p:nvSpPr>
+          <p:cNvPr id="21" name="TextBox 20"/>
           <p:cNvSpPr txBox="1"/>
           <p:nvPr/>
         </p:nvSpPr>
         <p:spPr>
           <a:xfrm>
-            <a:off x="320040" y="2020824"/>
-            <a:ext cx="1737360" cy="960119"/>
+            <a:off x="365760" y="2011680"/>
+            <a:ext cx="1691640" cy="914400"/>
           </a:xfrm>
           <a:prstGeom prst="rect">
             <a:avLst/>
@@ -3774,7 +3946,7 @@
             <a:r>
               <a:rPr sz="1100" b="1">
                 <a:solidFill>
-                  <a:srgbClr val="1B2A4A"/>
+                  <a:srgbClr val="1A1A1A"/>
                 </a:solidFill>
                 <a:latin typeface="Microsoft YaHei"/>
                 <a:ea typeface="Microsoft YaHei"/>
@@ -3788,14 +3960,14 @@
       </p:sp>
       <p:sp>
         <p:nvSpPr>
-          <p:cNvPr id="18" name="TextBox 17"/>
+          <p:cNvPr id="22" name="TextBox 21"/>
           <p:cNvSpPr txBox="1"/>
           <p:nvPr/>
         </p:nvSpPr>
         <p:spPr>
           <a:xfrm>
-            <a:off x="2194560" y="2002536"/>
-            <a:ext cx="4709160" cy="978407"/>
+            <a:off x="2194560" y="1993392"/>
+            <a:ext cx="4709160" cy="950976"/>
           </a:xfrm>
           <a:prstGeom prst="rect">
             <a:avLst/>
@@ -3819,7 +3991,7 @@
             <a:r>
               <a:rPr sz="950" b="0">
                 <a:solidFill>
-                  <a:srgbClr val="1F2937"/>
+                  <a:srgbClr val="4A4A4A"/>
                 </a:solidFill>
                 <a:latin typeface="Microsoft YaHei"/>
                 <a:ea typeface="Microsoft YaHei"/>
@@ -3834,14 +4006,14 @@
       </p:sp>
       <p:sp>
         <p:nvSpPr>
-          <p:cNvPr id="19" name="TextBox 18"/>
+          <p:cNvPr id="23" name="TextBox 22"/>
           <p:cNvSpPr txBox="1"/>
           <p:nvPr/>
         </p:nvSpPr>
         <p:spPr>
           <a:xfrm>
-            <a:off x="7132320" y="2002536"/>
-            <a:ext cx="4709160" cy="978407"/>
+            <a:off x="7132320" y="1993392"/>
+            <a:ext cx="4709160" cy="950976"/>
           </a:xfrm>
           <a:prstGeom prst="rect">
             <a:avLst/>
@@ -3865,7 +4037,7 @@
             <a:r>
               <a:rPr sz="950" b="0">
                 <a:solidFill>
-                  <a:srgbClr val="1F2937"/>
+                  <a:srgbClr val="4A4A4A"/>
                 </a:solidFill>
                 <a:latin typeface="Microsoft YaHei"/>
                 <a:ea typeface="Microsoft YaHei"/>
@@ -3881,20 +4053,20 @@
       </p:sp>
       <p:sp>
         <p:nvSpPr>
-          <p:cNvPr id="20" name="Rectangle 19"/>
+          <p:cNvPr id="24" name="Rectangle 23"/>
           <p:cNvSpPr/>
           <p:nvPr/>
         </p:nvSpPr>
         <p:spPr>
           <a:xfrm>
-            <a:off x="182880" y="2999232"/>
-            <a:ext cx="11841480" cy="960120"/>
+            <a:off x="228600" y="2962656"/>
+            <a:ext cx="11750040" cy="932688"/>
           </a:xfrm>
           <a:prstGeom prst="rect">
             <a:avLst/>
           </a:prstGeom>
           <a:solidFill>
-            <a:srgbClr val="F5F7FA"/>
+            <a:srgbClr val="F5F5F5"/>
           </a:solidFill>
           <a:ln>
             <a:noFill/>
@@ -3924,20 +4096,20 @@
       </p:sp>
       <p:sp>
         <p:nvSpPr>
-          <p:cNvPr id="21" name="Rectangle 20"/>
+          <p:cNvPr id="25" name="Rectangle 24"/>
           <p:cNvSpPr/>
           <p:nvPr/>
         </p:nvSpPr>
         <p:spPr>
           <a:xfrm>
-            <a:off x="182880" y="2999232"/>
-            <a:ext cx="73152" cy="960120"/>
+            <a:off x="228600" y="2962656"/>
+            <a:ext cx="64008" cy="932688"/>
           </a:xfrm>
           <a:prstGeom prst="rect">
             <a:avLst/>
           </a:prstGeom>
           <a:solidFill>
-            <a:srgbClr val="1B2A4A"/>
+            <a:srgbClr val="C4281C"/>
           </a:solidFill>
           <a:ln>
             <a:noFill/>
@@ -3967,14 +4139,57 @@
       </p:sp>
       <p:sp>
         <p:nvSpPr>
-          <p:cNvPr id="22" name="TextBox 21"/>
+          <p:cNvPr id="26" name="Rectangle 25"/>
+          <p:cNvSpPr/>
+          <p:nvPr/>
+        </p:nvSpPr>
+        <p:spPr>
+          <a:xfrm>
+            <a:off x="228600" y="3884371"/>
+            <a:ext cx="11750040" cy="10972"/>
+          </a:xfrm>
+          <a:prstGeom prst="rect">
+            <a:avLst/>
+          </a:prstGeom>
+          <a:solidFill>
+            <a:srgbClr val="D0D0D0"/>
+          </a:solidFill>
+          <a:ln>
+            <a:noFill/>
+          </a:ln>
+        </p:spPr>
+        <p:style>
+          <a:lnRef idx="1">
+            <a:schemeClr val="accent1"/>
+          </a:lnRef>
+          <a:fillRef idx="3">
+            <a:schemeClr val="accent1"/>
+          </a:fillRef>
+          <a:effectRef idx="2">
+            <a:schemeClr val="accent1"/>
+          </a:effectRef>
+          <a:fontRef idx="minor">
+            <a:schemeClr val="lt1"/>
+          </a:fontRef>
+        </p:style>
+        <p:txBody>
+          <a:bodyPr rtlCol="0" anchor="ctr"/>
+          <a:lstStyle/>
+          <a:p>
+            <a:pPr algn="ctr"/>
+          </a:p>
+        </p:txBody>
+      </p:sp>
+      <p:sp>
+        <p:nvSpPr>
+          <p:cNvPr id="27" name="TextBox 26"/>
           <p:cNvSpPr txBox="1"/>
           <p:nvPr/>
         </p:nvSpPr>
         <p:spPr>
           <a:xfrm>
-            <a:off x="320040" y="3072384"/>
-            <a:ext cx="1737360" cy="868680"/>
+            <a:off x="365760" y="3035808"/>
+            <a:ext cx="1691640" cy="822960"/>
           </a:xfrm>
           <a:prstGeom prst="rect">
             <a:avLst/>
@@ -3998,7 +4213,7 @@
             <a:r>
               <a:rPr sz="1100" b="1">
                 <a:solidFill>
-                  <a:srgbClr val="1B2A4A"/>
+                  <a:srgbClr val="1A1A1A"/>
                 </a:solidFill>
                 <a:latin typeface="Microsoft YaHei"/>
                 <a:ea typeface="Microsoft YaHei"/>
@@ -4011,14 +4226,14 @@
       </p:sp>
       <p:sp>
         <p:nvSpPr>
-          <p:cNvPr id="23" name="TextBox 22"/>
+          <p:cNvPr id="28" name="TextBox 27"/>
           <p:cNvSpPr txBox="1"/>
           <p:nvPr/>
         </p:nvSpPr>
         <p:spPr>
           <a:xfrm>
-            <a:off x="2194560" y="3054096"/>
-            <a:ext cx="4709160" cy="886968"/>
+            <a:off x="2194560" y="3017520"/>
+            <a:ext cx="4709160" cy="859536"/>
           </a:xfrm>
           <a:prstGeom prst="rect">
             <a:avLst/>
@@ -4042,7 +4257,7 @@
             <a:r>
               <a:rPr sz="950" b="0">
                 <a:solidFill>
-                  <a:srgbClr val="1F2937"/>
+                  <a:srgbClr val="4A4A4A"/>
                 </a:solidFill>
                 <a:latin typeface="Microsoft YaHei"/>
                 <a:ea typeface="Microsoft YaHei"/>
@@ -4058,14 +4273,14 @@
       </p:sp>
       <p:sp>
         <p:nvSpPr>
-          <p:cNvPr id="24" name="TextBox 23"/>
+          <p:cNvPr id="29" name="TextBox 28"/>
           <p:cNvSpPr txBox="1"/>
           <p:nvPr/>
         </p:nvSpPr>
         <p:spPr>
           <a:xfrm>
-            <a:off x="7132320" y="3054096"/>
-            <a:ext cx="4709160" cy="886968"/>
+            <a:off x="7132320" y="3017520"/>
+            <a:ext cx="4709160" cy="859536"/>
           </a:xfrm>
           <a:prstGeom prst="rect">
             <a:avLst/>
@@ -4089,7 +4304,7 @@
             <a:r>
               <a:rPr sz="950" b="0">
                 <a:solidFill>
-                  <a:srgbClr val="1F2937"/>
+                  <a:srgbClr val="4A4A4A"/>
                 </a:solidFill>
                 <a:latin typeface="Microsoft YaHei"/>
                 <a:ea typeface="Microsoft YaHei"/>
@@ -4106,14 +4321,14 @@
       </p:sp>
       <p:sp>
         <p:nvSpPr>
-          <p:cNvPr id="25" name="Rectangle 24"/>
+          <p:cNvPr id="30" name="Rectangle 29"/>
           <p:cNvSpPr/>
           <p:nvPr/>
         </p:nvSpPr>
         <p:spPr>
           <a:xfrm>
-            <a:off x="182880" y="3959352"/>
-            <a:ext cx="11841480" cy="777240"/>
+            <a:off x="228600" y="3895344"/>
+            <a:ext cx="11750040" cy="749808"/>
           </a:xfrm>
           <a:prstGeom prst="rect">
             <a:avLst/>
@@ -4149,20 +4364,20 @@
       </p:sp>
       <p:sp>
         <p:nvSpPr>
-          <p:cNvPr id="26" name="Rectangle 25"/>
+          <p:cNvPr id="31" name="Rectangle 30"/>
           <p:cNvSpPr/>
           <p:nvPr/>
         </p:nvSpPr>
         <p:spPr>
           <a:xfrm>
-            <a:off x="182880" y="3959352"/>
-            <a:ext cx="73152" cy="777240"/>
+            <a:off x="228600" y="3895344"/>
+            <a:ext cx="64008" cy="749808"/>
           </a:xfrm>
           <a:prstGeom prst="rect">
             <a:avLst/>
           </a:prstGeom>
           <a:solidFill>
-            <a:srgbClr val="1B2A4A"/>
+            <a:srgbClr val="C4281C"/>
           </a:solidFill>
           <a:ln>
             <a:noFill/>
@@ -4192,14 +4407,57 @@
       </p:sp>
       <p:sp>
         <p:nvSpPr>
-          <p:cNvPr id="27" name="TextBox 26"/>
+          <p:cNvPr id="32" name="Rectangle 31"/>
+          <p:cNvSpPr/>
+          <p:nvPr/>
+        </p:nvSpPr>
+        <p:spPr>
+          <a:xfrm>
+            <a:off x="228600" y="4634179"/>
+            <a:ext cx="11750040" cy="10972"/>
+          </a:xfrm>
+          <a:prstGeom prst="rect">
+            <a:avLst/>
+          </a:prstGeom>
+          <a:solidFill>
+            <a:srgbClr val="D0D0D0"/>
+          </a:solidFill>
+          <a:ln>
+            <a:noFill/>
+          </a:ln>
+        </p:spPr>
+        <p:style>
+          <a:lnRef idx="1">
+            <a:schemeClr val="accent1"/>
+          </a:lnRef>
+          <a:fillRef idx="3">
+            <a:schemeClr val="accent1"/>
+          </a:fillRef>
+          <a:effectRef idx="2">
+            <a:schemeClr val="accent1"/>
+          </a:effectRef>
+          <a:fontRef idx="minor">
+            <a:schemeClr val="lt1"/>
+          </a:fontRef>
+        </p:style>
+        <p:txBody>
+          <a:bodyPr rtlCol="0" anchor="ctr"/>
+          <a:lstStyle/>
+          <a:p>
+            <a:pPr algn="ctr"/>
+          </a:p>
+        </p:txBody>
+      </p:sp>
+      <p:sp>
+        <p:nvSpPr>
+          <p:cNvPr id="33" name="TextBox 32"/>
           <p:cNvSpPr txBox="1"/>
           <p:nvPr/>
         </p:nvSpPr>
         <p:spPr>
           <a:xfrm>
-            <a:off x="320040" y="4032504"/>
-            <a:ext cx="1737360" cy="685800"/>
+            <a:off x="365760" y="3968496"/>
+            <a:ext cx="1691640" cy="640080"/>
           </a:xfrm>
           <a:prstGeom prst="rect">
             <a:avLst/>
@@ -4223,7 +4481,7 @@
             <a:r>
               <a:rPr sz="1100" b="1">
                 <a:solidFill>
-                  <a:srgbClr val="1B2A4A"/>
+                  <a:srgbClr val="1A1A1A"/>
                 </a:solidFill>
                 <a:latin typeface="Microsoft YaHei"/>
                 <a:ea typeface="Microsoft YaHei"/>
@@ -4237,14 +4495,14 @@
       </p:sp>
       <p:sp>
         <p:nvSpPr>
-          <p:cNvPr id="28" name="TextBox 27"/>
+          <p:cNvPr id="34" name="TextBox 33"/>
           <p:cNvSpPr txBox="1"/>
           <p:nvPr/>
         </p:nvSpPr>
         <p:spPr>
           <a:xfrm>
-            <a:off x="2194560" y="4014215"/>
-            <a:ext cx="4709160" cy="704088"/>
+            <a:off x="2194560" y="3950207"/>
+            <a:ext cx="4709160" cy="676656"/>
           </a:xfrm>
           <a:prstGeom prst="rect">
             <a:avLst/>
@@ -4268,7 +4526,7 @@
             <a:r>
               <a:rPr sz="950" b="0">
                 <a:solidFill>
-                  <a:srgbClr val="1F2937"/>
+                  <a:srgbClr val="4A4A4A"/>
                 </a:solidFill>
                 <a:latin typeface="Microsoft YaHei"/>
                 <a:ea typeface="Microsoft YaHei"/>
@@ -4283,14 +4541,14 @@
       </p:sp>
       <p:sp>
         <p:nvSpPr>
-          <p:cNvPr id="29" name="TextBox 28"/>
+          <p:cNvPr id="35" name="TextBox 34"/>
           <p:cNvSpPr txBox="1"/>
           <p:nvPr/>
         </p:nvSpPr>
         <p:spPr>
           <a:xfrm>
-            <a:off x="7132320" y="4014215"/>
-            <a:ext cx="4709160" cy="704088"/>
+            <a:off x="7132320" y="3950207"/>
+            <a:ext cx="4709160" cy="676656"/>
           </a:xfrm>
           <a:prstGeom prst="rect">
             <a:avLst/>
@@ -4314,7 +4572,7 @@
             <a:r>
               <a:rPr sz="950" b="0">
                 <a:solidFill>
-                  <a:srgbClr val="1F2937"/>
+                  <a:srgbClr val="4A4A4A"/>
                 </a:solidFill>
                 <a:latin typeface="Microsoft YaHei"/>
                 <a:ea typeface="Microsoft YaHei"/>
@@ -4328,20 +4586,20 @@
       </p:sp>
       <p:sp>
         <p:nvSpPr>
-          <p:cNvPr id="30" name="Rectangle 29"/>
+          <p:cNvPr id="36" name="Rectangle 35"/>
           <p:cNvSpPr/>
           <p:nvPr/>
         </p:nvSpPr>
         <p:spPr>
           <a:xfrm>
-            <a:off x="182880" y="4736592"/>
-            <a:ext cx="11841480" cy="685800"/>
+            <a:off x="228600" y="4645152"/>
+            <a:ext cx="11750040" cy="658368"/>
           </a:xfrm>
           <a:prstGeom prst="rect">
             <a:avLst/>
           </a:prstGeom>
           <a:solidFill>
-            <a:srgbClr val="F5F7FA"/>
+            <a:srgbClr val="F5F5F5"/>
           </a:solidFill>
           <a:ln>
             <a:noFill/>
@@ -4371,20 +4629,20 @@
       </p:sp>
       <p:sp>
         <p:nvSpPr>
-          <p:cNvPr id="31" name="Rectangle 30"/>
+          <p:cNvPr id="37" name="Rectangle 36"/>
           <p:cNvSpPr/>
           <p:nvPr/>
         </p:nvSpPr>
         <p:spPr>
           <a:xfrm>
-            <a:off x="182880" y="4736592"/>
-            <a:ext cx="73152" cy="685800"/>
+            <a:off x="228600" y="4645152"/>
+            <a:ext cx="64008" cy="658368"/>
           </a:xfrm>
           <a:prstGeom prst="rect">
             <a:avLst/>
           </a:prstGeom>
           <a:solidFill>
-            <a:srgbClr val="1B2A4A"/>
+            <a:srgbClr val="C4281C"/>
           </a:solidFill>
           <a:ln>
             <a:noFill/>
@@ -4414,14 +4672,57 @@
       </p:sp>
       <p:sp>
         <p:nvSpPr>
-          <p:cNvPr id="32" name="TextBox 31"/>
+          <p:cNvPr id="38" name="Rectangle 37"/>
+          <p:cNvSpPr/>
+          <p:nvPr/>
+        </p:nvSpPr>
+        <p:spPr>
+          <a:xfrm>
+            <a:off x="228600" y="5292547"/>
+            <a:ext cx="11750040" cy="10972"/>
+          </a:xfrm>
+          <a:prstGeom prst="rect">
+            <a:avLst/>
+          </a:prstGeom>
+          <a:solidFill>
+            <a:srgbClr val="D0D0D0"/>
+          </a:solidFill>
+          <a:ln>
+            <a:noFill/>
+          </a:ln>
+        </p:spPr>
+        <p:style>
+          <a:lnRef idx="1">
+            <a:schemeClr val="accent1"/>
+          </a:lnRef>
+          <a:fillRef idx="3">
+            <a:schemeClr val="accent1"/>
+          </a:fillRef>
+          <a:effectRef idx="2">
+            <a:schemeClr val="accent1"/>
+          </a:effectRef>
+          <a:fontRef idx="minor">
+            <a:schemeClr val="lt1"/>
+          </a:fontRef>
+        </p:style>
+        <p:txBody>
+          <a:bodyPr rtlCol="0" anchor="ctr"/>
+          <a:lstStyle/>
+          <a:p>
+            <a:pPr algn="ctr"/>
+          </a:p>
+        </p:txBody>
+      </p:sp>
+      <p:sp>
+        <p:nvSpPr>
+          <p:cNvPr id="39" name="TextBox 38"/>
           <p:cNvSpPr txBox="1"/>
           <p:nvPr/>
         </p:nvSpPr>
         <p:spPr>
           <a:xfrm>
-            <a:off x="320040" y="4809744"/>
-            <a:ext cx="1737360" cy="594360"/>
+            <a:off x="365760" y="4718304"/>
+            <a:ext cx="1691640" cy="548640"/>
           </a:xfrm>
           <a:prstGeom prst="rect">
             <a:avLst/>
@@ -4445,7 +4746,7 @@
             <a:r>
               <a:rPr sz="1100" b="1">
                 <a:solidFill>
-                  <a:srgbClr val="1B2A4A"/>
+                  <a:srgbClr val="1A1A1A"/>
                 </a:solidFill>
                 <a:latin typeface="Microsoft YaHei"/>
                 <a:ea typeface="Microsoft YaHei"/>
@@ -4458,14 +4759,14 @@
       </p:sp>
       <p:sp>
         <p:nvSpPr>
-          <p:cNvPr id="33" name="TextBox 32"/>
+          <p:cNvPr id="40" name="TextBox 39"/>
           <p:cNvSpPr txBox="1"/>
           <p:nvPr/>
         </p:nvSpPr>
         <p:spPr>
           <a:xfrm>
-            <a:off x="2194560" y="4791455"/>
-            <a:ext cx="4709160" cy="612648"/>
+            <a:off x="2194560" y="4700016"/>
+            <a:ext cx="4709160" cy="585216"/>
           </a:xfrm>
           <a:prstGeom prst="rect">
             <a:avLst/>
@@ -4489,7 +4790,7 @@
             <a:r>
               <a:rPr sz="950" b="0">
                 <a:solidFill>
-                  <a:srgbClr val="1F2937"/>
+                  <a:srgbClr val="4A4A4A"/>
                 </a:solidFill>
                 <a:latin typeface="Microsoft YaHei"/>
                 <a:ea typeface="Microsoft YaHei"/>
@@ -4504,14 +4805,14 @@
       </p:sp>
       <p:sp>
         <p:nvSpPr>
-          <p:cNvPr id="34" name="TextBox 33"/>
+          <p:cNvPr id="41" name="TextBox 40"/>
           <p:cNvSpPr txBox="1"/>
           <p:nvPr/>
         </p:nvSpPr>
         <p:spPr>
           <a:xfrm>
-            <a:off x="7132320" y="4791455"/>
-            <a:ext cx="4709160" cy="612648"/>
+            <a:off x="7132320" y="4700016"/>
+            <a:ext cx="4709160" cy="585216"/>
           </a:xfrm>
           <a:prstGeom prst="rect">
             <a:avLst/>
@@ -4535,7 +4836,7 @@
             <a:r>
               <a:rPr sz="950" b="0">
                 <a:solidFill>
-                  <a:srgbClr val="1F2937"/>
+                  <a:srgbClr val="4A4A4A"/>
                 </a:solidFill>
                 <a:latin typeface="Microsoft YaHei"/>
                 <a:ea typeface="Microsoft YaHei"/>
@@ -4550,23 +4851,25 @@
       </p:sp>
       <p:sp>
         <p:nvSpPr>
-          <p:cNvPr id="35" name="Rectangle 34"/>
+          <p:cNvPr id="42" name="Rectangle 41"/>
           <p:cNvSpPr/>
           <p:nvPr/>
         </p:nvSpPr>
         <p:spPr>
           <a:xfrm>
-            <a:off x="182880" y="5495544"/>
-            <a:ext cx="11841480" cy="1417320"/>
+            <a:off x="228600" y="5394959"/>
+            <a:ext cx="11750040" cy="1353312"/>
           </a:xfrm>
           <a:prstGeom prst="rect">
             <a:avLst/>
           </a:prstGeom>
           <a:solidFill>
-            <a:srgbClr val="EEF2F7"/>
+            <a:srgbClr val="FFFFFF"/>
           </a:solidFill>
-          <a:ln>
-            <a:noFill/>
+          <a:ln w="9525">
+            <a:solidFill>
+              <a:srgbClr val="D0D0D0"/>
+            </a:solidFill>
           </a:ln>
         </p:spPr>
         <p:style>
@@ -4593,14 +4896,57 @@
       </p:sp>
       <p:sp>
         <p:nvSpPr>
-          <p:cNvPr id="36" name="TextBox 35"/>
+          <p:cNvPr id="43" name="Rectangle 42"/>
+          <p:cNvSpPr/>
+          <p:nvPr/>
+        </p:nvSpPr>
+        <p:spPr>
+          <a:xfrm>
+            <a:off x="228600" y="5394959"/>
+            <a:ext cx="64008" cy="1353312"/>
+          </a:xfrm>
+          <a:prstGeom prst="rect">
+            <a:avLst/>
+          </a:prstGeom>
+          <a:solidFill>
+            <a:srgbClr val="C4281C"/>
+          </a:solidFill>
+          <a:ln>
+            <a:noFill/>
+          </a:ln>
+        </p:spPr>
+        <p:style>
+          <a:lnRef idx="1">
+            <a:schemeClr val="accent1"/>
+          </a:lnRef>
+          <a:fillRef idx="3">
+            <a:schemeClr val="accent1"/>
+          </a:fillRef>
+          <a:effectRef idx="2">
+            <a:schemeClr val="accent1"/>
+          </a:effectRef>
+          <a:fontRef idx="minor">
+            <a:schemeClr val="lt1"/>
+          </a:fontRef>
+        </p:style>
+        <p:txBody>
+          <a:bodyPr rtlCol="0" anchor="ctr"/>
+          <a:lstStyle/>
+          <a:p>
+            <a:pPr algn="ctr"/>
+          </a:p>
+        </p:txBody>
+      </p:sp>
+      <p:sp>
+        <p:nvSpPr>
+          <p:cNvPr id="44" name="TextBox 43"/>
           <p:cNvSpPr txBox="1"/>
           <p:nvPr/>
         </p:nvSpPr>
         <p:spPr>
           <a:xfrm>
-            <a:off x="320040" y="5550407"/>
-            <a:ext cx="11521440" cy="256032"/>
+            <a:off x="411480" y="5449823"/>
+            <a:ext cx="11338560" cy="256032"/>
           </a:xfrm>
           <a:prstGeom prst="rect">
             <a:avLst/>
@@ -4624,7 +4970,7 @@
             <a:r>
               <a:rPr sz="1200" b="1">
                 <a:solidFill>
-                  <a:srgbClr val="1B2A4A"/>
+                  <a:srgbClr val="C4281C"/>
                 </a:solidFill>
                 <a:latin typeface="Microsoft YaHei"/>
                 <a:ea typeface="Microsoft YaHei"/>
@@ -4637,14 +4983,14 @@
       </p:sp>
       <p:sp>
         <p:nvSpPr>
-          <p:cNvPr id="37" name="TextBox 36"/>
+          <p:cNvPr id="45" name="TextBox 44"/>
           <p:cNvSpPr txBox="1"/>
           <p:nvPr/>
         </p:nvSpPr>
         <p:spPr>
           <a:xfrm>
-            <a:off x="320040" y="5806440"/>
-            <a:ext cx="11521440" cy="1051560"/>
+            <a:off x="411480" y="5705855"/>
+            <a:ext cx="11338560" cy="987552"/>
           </a:xfrm>
           <a:prstGeom prst="rect">
             <a:avLst/>
@@ -4668,7 +5014,7 @@
             <a:r>
               <a:rPr sz="900" b="0">
                 <a:solidFill>
-                  <a:srgbClr val="4B5563"/>
+                  <a:srgbClr val="4A4A4A"/>
                 </a:solidFill>
                 <a:latin typeface="Microsoft YaHei"/>
                 <a:ea typeface="Microsoft YaHei"/>
@@ -4686,14 +5032,14 @@
       </p:sp>
       <p:sp>
         <p:nvSpPr>
-          <p:cNvPr id="38" name="TextBox 37"/>
+          <p:cNvPr id="46" name="TextBox 45"/>
           <p:cNvSpPr txBox="1"/>
           <p:nvPr/>
         </p:nvSpPr>
         <p:spPr>
           <a:xfrm>
-            <a:off x="274320" y="6537960"/>
-            <a:ext cx="11704320" cy="256032"/>
+            <a:off x="320040" y="6565392"/>
+            <a:ext cx="11612880" cy="237744"/>
           </a:xfrm>
           <a:prstGeom prst="rect">
             <a:avLst/>
@@ -4717,7 +5063,7 @@
             <a:r>
               <a:rPr sz="800" b="0">
                 <a:solidFill>
-                  <a:srgbClr val="8B94A3"/>
+                  <a:srgbClr val="8A8A8A"/>
                 </a:solidFill>
                 <a:latin typeface="Microsoft YaHei"/>
                 <a:ea typeface="Microsoft YaHei"/>

</xml_diff>